<commit_message>
h1 tests and analysis implemented
</commit_message>
<xml_diff>
--- a/presentation/dynamic_test_time_compute_allocation.pptx
+++ b/presentation/dynamic_test_time_compute_allocation.pptx
@@ -5614,7 +5614,7 @@
         <p:fade/>
       </p:transition>
     </mc:Choice>
-    <mc:Fallback xmlns="" xmlns:mv="urn:schemas-microsoft-com:mac:vml" xmlns:c="http://schemas.openxmlformats.org/drawingml/2006/chart" xmlns:dgm="http://schemas.openxmlformats.org/drawingml/2006/diagram" xmlns:o="urn:schemas-microsoft-com:office:office" xmlns:v="urn:schemas-microsoft-com:vml" xmlns:pvml="urn:schemas-microsoft-com:office:powerpoint" xmlns:com="http://schemas.openxmlformats.org/drawingml/2006/compatibility" xmlns:p15="http://schemas.microsoft.com/office/powerpoint/2012/main" xmlns:ahyp="http://schemas.microsoft.com/office/drawing/2018/hyperlinkcolor">
+    <mc:Fallback xmlns:ahyp="http://schemas.microsoft.com/office/drawing/2018/hyperlinkcolor" xmlns:p15="http://schemas.microsoft.com/office/powerpoint/2012/main" xmlns:com="http://schemas.openxmlformats.org/drawingml/2006/compatibility" xmlns:pvml="urn:schemas-microsoft-com:office:powerpoint" xmlns:v="urn:schemas-microsoft-com:vml" xmlns:o="urn:schemas-microsoft-com:office:office" xmlns:dgm="http://schemas.openxmlformats.org/drawingml/2006/diagram" xmlns:c="http://schemas.openxmlformats.org/drawingml/2006/chart" xmlns:mv="urn:schemas-microsoft-com:mac:vml" xmlns="">
       <p:transition spd="slow">
         <p:fade/>
       </p:transition>
@@ -5898,7 +5898,7 @@
         <p:fade/>
       </p:transition>
     </mc:Choice>
-    <mc:Fallback xmlns="" xmlns:mv="urn:schemas-microsoft-com:mac:vml" xmlns:c="http://schemas.openxmlformats.org/drawingml/2006/chart" xmlns:dgm="http://schemas.openxmlformats.org/drawingml/2006/diagram" xmlns:o="urn:schemas-microsoft-com:office:office" xmlns:v="urn:schemas-microsoft-com:vml" xmlns:pvml="urn:schemas-microsoft-com:office:powerpoint" xmlns:com="http://schemas.openxmlformats.org/drawingml/2006/compatibility" xmlns:p15="http://schemas.microsoft.com/office/powerpoint/2012/main" xmlns:ahyp="http://schemas.microsoft.com/office/drawing/2018/hyperlinkcolor">
+    <mc:Fallback xmlns:ahyp="http://schemas.microsoft.com/office/drawing/2018/hyperlinkcolor" xmlns:p15="http://schemas.microsoft.com/office/powerpoint/2012/main" xmlns:com="http://schemas.openxmlformats.org/drawingml/2006/compatibility" xmlns:pvml="urn:schemas-microsoft-com:office:powerpoint" xmlns:v="urn:schemas-microsoft-com:vml" xmlns:o="urn:schemas-microsoft-com:office:office" xmlns:dgm="http://schemas.openxmlformats.org/drawingml/2006/diagram" xmlns:c="http://schemas.openxmlformats.org/drawingml/2006/chart" xmlns:mv="urn:schemas-microsoft-com:mac:vml" xmlns="">
       <p:transition spd="slow">
         <p:fade/>
       </p:transition>
@@ -6178,7 +6178,7 @@
         <p:fade/>
       </p:transition>
     </mc:Choice>
-    <mc:Fallback xmlns="" xmlns:mv="urn:schemas-microsoft-com:mac:vml" xmlns:c="http://schemas.openxmlformats.org/drawingml/2006/chart" xmlns:dgm="http://schemas.openxmlformats.org/drawingml/2006/diagram" xmlns:o="urn:schemas-microsoft-com:office:office" xmlns:v="urn:schemas-microsoft-com:vml" xmlns:pvml="urn:schemas-microsoft-com:office:powerpoint" xmlns:com="http://schemas.openxmlformats.org/drawingml/2006/compatibility" xmlns:p15="http://schemas.microsoft.com/office/powerpoint/2012/main" xmlns:ahyp="http://schemas.microsoft.com/office/drawing/2018/hyperlinkcolor">
+    <mc:Fallback xmlns:ahyp="http://schemas.microsoft.com/office/drawing/2018/hyperlinkcolor" xmlns:p15="http://schemas.microsoft.com/office/powerpoint/2012/main" xmlns:com="http://schemas.openxmlformats.org/drawingml/2006/compatibility" xmlns:pvml="urn:schemas-microsoft-com:office:powerpoint" xmlns:v="urn:schemas-microsoft-com:vml" xmlns:o="urn:schemas-microsoft-com:office:office" xmlns:dgm="http://schemas.openxmlformats.org/drawingml/2006/diagram" xmlns:c="http://schemas.openxmlformats.org/drawingml/2006/chart" xmlns:mv="urn:schemas-microsoft-com:mac:vml" xmlns="">
       <p:transition spd="slow">
         <p:fade/>
       </p:transition>
@@ -6829,7 +6829,7 @@
         <p:fade/>
       </p:transition>
     </mc:Choice>
-    <mc:Fallback xmlns="" xmlns:mv="urn:schemas-microsoft-com:mac:vml" xmlns:c="http://schemas.openxmlformats.org/drawingml/2006/chart" xmlns:dgm="http://schemas.openxmlformats.org/drawingml/2006/diagram" xmlns:o="urn:schemas-microsoft-com:office:office" xmlns:v="urn:schemas-microsoft-com:vml" xmlns:pvml="urn:schemas-microsoft-com:office:powerpoint" xmlns:com="http://schemas.openxmlformats.org/drawingml/2006/compatibility" xmlns:p15="http://schemas.microsoft.com/office/powerpoint/2012/main" xmlns:ahyp="http://schemas.microsoft.com/office/drawing/2018/hyperlinkcolor">
+    <mc:Fallback xmlns:ahyp="http://schemas.microsoft.com/office/drawing/2018/hyperlinkcolor" xmlns:p15="http://schemas.microsoft.com/office/powerpoint/2012/main" xmlns:com="http://schemas.openxmlformats.org/drawingml/2006/compatibility" xmlns:pvml="urn:schemas-microsoft-com:office:powerpoint" xmlns:v="urn:schemas-microsoft-com:vml" xmlns:o="urn:schemas-microsoft-com:office:office" xmlns:dgm="http://schemas.openxmlformats.org/drawingml/2006/diagram" xmlns:c="http://schemas.openxmlformats.org/drawingml/2006/chart" xmlns:mv="urn:schemas-microsoft-com:mac:vml" xmlns="">
       <p:transition spd="slow">
         <p:fade/>
       </p:transition>
@@ -7862,7 +7862,7 @@
         <p:fade/>
       </p:transition>
     </mc:Choice>
-    <mc:Fallback xmlns="" xmlns:mv="urn:schemas-microsoft-com:mac:vml" xmlns:c="http://schemas.openxmlformats.org/drawingml/2006/chart" xmlns:dgm="http://schemas.openxmlformats.org/drawingml/2006/diagram" xmlns:o="urn:schemas-microsoft-com:office:office" xmlns:v="urn:schemas-microsoft-com:vml" xmlns:pvml="urn:schemas-microsoft-com:office:powerpoint" xmlns:com="http://schemas.openxmlformats.org/drawingml/2006/compatibility" xmlns:p15="http://schemas.microsoft.com/office/powerpoint/2012/main" xmlns:ahyp="http://schemas.microsoft.com/office/drawing/2018/hyperlinkcolor">
+    <mc:Fallback xmlns:ahyp="http://schemas.microsoft.com/office/drawing/2018/hyperlinkcolor" xmlns:p15="http://schemas.microsoft.com/office/powerpoint/2012/main" xmlns:com="http://schemas.openxmlformats.org/drawingml/2006/compatibility" xmlns:pvml="urn:schemas-microsoft-com:office:powerpoint" xmlns:v="urn:schemas-microsoft-com:vml" xmlns:o="urn:schemas-microsoft-com:office:office" xmlns:dgm="http://schemas.openxmlformats.org/drawingml/2006/diagram" xmlns:c="http://schemas.openxmlformats.org/drawingml/2006/chart" xmlns:mv="urn:schemas-microsoft-com:mac:vml" xmlns="">
       <p:transition spd="slow">
         <p:fade/>
       </p:transition>
@@ -8131,7 +8131,7 @@
         <p:fade/>
       </p:transition>
     </mc:Choice>
-    <mc:Fallback xmlns="" xmlns:mv="urn:schemas-microsoft-com:mac:vml" xmlns:c="http://schemas.openxmlformats.org/drawingml/2006/chart" xmlns:dgm="http://schemas.openxmlformats.org/drawingml/2006/diagram" xmlns:o="urn:schemas-microsoft-com:office:office" xmlns:v="urn:schemas-microsoft-com:vml" xmlns:pvml="urn:schemas-microsoft-com:office:powerpoint" xmlns:com="http://schemas.openxmlformats.org/drawingml/2006/compatibility" xmlns:p15="http://schemas.microsoft.com/office/powerpoint/2012/main" xmlns:ahyp="http://schemas.microsoft.com/office/drawing/2018/hyperlinkcolor">
+    <mc:Fallback xmlns:ahyp="http://schemas.microsoft.com/office/drawing/2018/hyperlinkcolor" xmlns:p15="http://schemas.microsoft.com/office/powerpoint/2012/main" xmlns:com="http://schemas.openxmlformats.org/drawingml/2006/compatibility" xmlns:pvml="urn:schemas-microsoft-com:office:powerpoint" xmlns:v="urn:schemas-microsoft-com:vml" xmlns:o="urn:schemas-microsoft-com:office:office" xmlns:dgm="http://schemas.openxmlformats.org/drawingml/2006/diagram" xmlns:c="http://schemas.openxmlformats.org/drawingml/2006/chart" xmlns:mv="urn:schemas-microsoft-com:mac:vml" xmlns="">
       <p:transition spd="slow">
         <p:fade/>
       </p:transition>
@@ -8373,7 +8373,7 @@
         <p:fade/>
       </p:transition>
     </mc:Choice>
-    <mc:Fallback xmlns="" xmlns:mv="urn:schemas-microsoft-com:mac:vml" xmlns:c="http://schemas.openxmlformats.org/drawingml/2006/chart" xmlns:dgm="http://schemas.openxmlformats.org/drawingml/2006/diagram" xmlns:o="urn:schemas-microsoft-com:office:office" xmlns:v="urn:schemas-microsoft-com:vml" xmlns:pvml="urn:schemas-microsoft-com:office:powerpoint" xmlns:com="http://schemas.openxmlformats.org/drawingml/2006/compatibility" xmlns:p15="http://schemas.microsoft.com/office/powerpoint/2012/main" xmlns:ahyp="http://schemas.microsoft.com/office/drawing/2018/hyperlinkcolor">
+    <mc:Fallback xmlns:ahyp="http://schemas.microsoft.com/office/drawing/2018/hyperlinkcolor" xmlns:p15="http://schemas.microsoft.com/office/powerpoint/2012/main" xmlns:com="http://schemas.openxmlformats.org/drawingml/2006/compatibility" xmlns:pvml="urn:schemas-microsoft-com:office:powerpoint" xmlns:v="urn:schemas-microsoft-com:vml" xmlns:o="urn:schemas-microsoft-com:office:office" xmlns:dgm="http://schemas.openxmlformats.org/drawingml/2006/diagram" xmlns:c="http://schemas.openxmlformats.org/drawingml/2006/chart" xmlns:mv="urn:schemas-microsoft-com:mac:vml" xmlns="">
       <p:transition spd="slow">
         <p:fade/>
       </p:transition>
@@ -8478,7 +8478,7 @@
         <p:fade/>
       </p:transition>
     </mc:Choice>
-    <mc:Fallback xmlns="" xmlns:mv="urn:schemas-microsoft-com:mac:vml" xmlns:c="http://schemas.openxmlformats.org/drawingml/2006/chart" xmlns:dgm="http://schemas.openxmlformats.org/drawingml/2006/diagram" xmlns:o="urn:schemas-microsoft-com:office:office" xmlns:v="urn:schemas-microsoft-com:vml" xmlns:pvml="urn:schemas-microsoft-com:office:powerpoint" xmlns:com="http://schemas.openxmlformats.org/drawingml/2006/compatibility" xmlns:p15="http://schemas.microsoft.com/office/powerpoint/2012/main" xmlns:ahyp="http://schemas.microsoft.com/office/drawing/2018/hyperlinkcolor">
+    <mc:Fallback xmlns:ahyp="http://schemas.microsoft.com/office/drawing/2018/hyperlinkcolor" xmlns:p15="http://schemas.microsoft.com/office/powerpoint/2012/main" xmlns:com="http://schemas.openxmlformats.org/drawingml/2006/compatibility" xmlns:pvml="urn:schemas-microsoft-com:office:powerpoint" xmlns:v="urn:schemas-microsoft-com:vml" xmlns:o="urn:schemas-microsoft-com:office:office" xmlns:dgm="http://schemas.openxmlformats.org/drawingml/2006/diagram" xmlns:c="http://schemas.openxmlformats.org/drawingml/2006/chart" xmlns:mv="urn:schemas-microsoft-com:mac:vml" xmlns="">
       <p:transition spd="slow">
         <p:fade/>
       </p:transition>
@@ -9439,7 +9439,7 @@
         <p:fade/>
       </p:transition>
     </mc:Choice>
-    <mc:Fallback xmlns="" xmlns:mv="urn:schemas-microsoft-com:mac:vml" xmlns:c="http://schemas.openxmlformats.org/drawingml/2006/chart" xmlns:dgm="http://schemas.openxmlformats.org/drawingml/2006/diagram" xmlns:o="urn:schemas-microsoft-com:office:office" xmlns:v="urn:schemas-microsoft-com:vml" xmlns:pvml="urn:schemas-microsoft-com:office:powerpoint" xmlns:com="http://schemas.openxmlformats.org/drawingml/2006/compatibility" xmlns:p15="http://schemas.microsoft.com/office/powerpoint/2012/main" xmlns:ahyp="http://schemas.microsoft.com/office/drawing/2018/hyperlinkcolor">
+    <mc:Fallback xmlns:ahyp="http://schemas.microsoft.com/office/drawing/2018/hyperlinkcolor" xmlns:p15="http://schemas.microsoft.com/office/powerpoint/2012/main" xmlns:com="http://schemas.openxmlformats.org/drawingml/2006/compatibility" xmlns:pvml="urn:schemas-microsoft-com:office:powerpoint" xmlns:v="urn:schemas-microsoft-com:vml" xmlns:o="urn:schemas-microsoft-com:office:office" xmlns:dgm="http://schemas.openxmlformats.org/drawingml/2006/diagram" xmlns:c="http://schemas.openxmlformats.org/drawingml/2006/chart" xmlns:mv="urn:schemas-microsoft-com:mac:vml" xmlns="">
       <p:transition spd="slow">
         <p:fade/>
       </p:transition>
@@ -29455,7 +29455,7 @@
               <a:buNone/>
             </a:pPr>
             <a:r>
-              <a:rPr lang="en-US" sz="4000" dirty="0">
+              <a:rPr lang="en-US" sz="4000">
                 <a:solidFill>
                   <a:srgbClr val="FFFFFF"/>
                 </a:solidFill>

</xml_diff>